<commit_message>
v1.29: errores id_origen/id_operacion, exclusiones duplicados, repoblar desde Excel
Made-with: Cursor
</commit_message>
<xml_diff>
--- a/Propuesta_Dashboard_Flujo_Caja.pptx
+++ b/Propuesta_Dashboard_Flujo_Caja.pptx
@@ -1378,11 +1378,11 @@
             <a:avLst/>
           </a:prstGeom>
           <a:solidFill>
-            <a:srgbClr val="0D2137"/>
+            <a:srgbClr val="FFFFFF"/>
           </a:solidFill>
           <a:ln w="19050">
             <a:solidFill>
-              <a:srgbClr val="FFFFFF"/>
+              <a:srgbClr val="0D2137"/>
             </a:solidFill>
             <a:prstDash val="solid"/>
           </a:ln>
@@ -1390,7 +1390,7 @@
       </p:sp>
       <p:pic>
         <p:nvPicPr>
-          <p:cNvPr id="5" name="Image 0" descr="/Users/lucasb/Escritorio - MacBook Air de Lucas/Fornitalia/favicon.svg">    </p:cNvPr>
+          <p:cNvPr id="5" name="Image 0" descr="preencoded.png">    </p:cNvPr>
           <p:cNvPicPr>
             <a:picLocks noChangeAspect="1"/>
           </p:cNvPicPr>
@@ -1639,11 +1639,11 @@
             <a:avLst/>
           </a:prstGeom>
           <a:solidFill>
-            <a:srgbClr val="0D2137"/>
+            <a:srgbClr val="FFFFFF"/>
           </a:solidFill>
           <a:ln w="19050">
             <a:solidFill>
-              <a:srgbClr val="FFFFFF"/>
+              <a:srgbClr val="0D2137"/>
             </a:solidFill>
             <a:prstDash val="solid"/>
           </a:ln>
@@ -1651,7 +1651,7 @@
       </p:sp>
       <p:pic>
         <p:nvPicPr>
-          <p:cNvPr id="4" name="Image 0" descr="/Users/lucasb/Escritorio - MacBook Air de Lucas/Fornitalia/favicon.svg">    </p:cNvPr>
+          <p:cNvPr id="4" name="Image 0" descr="preencoded.png">    </p:cNvPr>
           <p:cNvPicPr>
             <a:picLocks noChangeAspect="1"/>
           </p:cNvPicPr>
@@ -2081,11 +2081,11 @@
             <a:avLst/>
           </a:prstGeom>
           <a:solidFill>
-            <a:srgbClr val="0D2137"/>
+            <a:srgbClr val="FFFFFF"/>
           </a:solidFill>
           <a:ln w="19050">
             <a:solidFill>
-              <a:srgbClr val="FFFFFF"/>
+              <a:srgbClr val="0D2137"/>
             </a:solidFill>
             <a:prstDash val="solid"/>
           </a:ln>
@@ -2093,7 +2093,7 @@
       </p:sp>
       <p:pic>
         <p:nvPicPr>
-          <p:cNvPr id="4" name="Image 0" descr="/Users/lucasb/Escritorio - MacBook Air de Lucas/Fornitalia/favicon.svg">    </p:cNvPr>
+          <p:cNvPr id="4" name="Image 0" descr="preencoded.png">    </p:cNvPr>
           <p:cNvPicPr>
             <a:picLocks noChangeAspect="1"/>
           </p:cNvPicPr>
@@ -3048,11 +3048,11 @@
             <a:avLst/>
           </a:prstGeom>
           <a:solidFill>
-            <a:srgbClr val="0D2137"/>
+            <a:srgbClr val="FFFFFF"/>
           </a:solidFill>
           <a:ln w="19050">
             <a:solidFill>
-              <a:srgbClr val="FFFFFF"/>
+              <a:srgbClr val="0D2137"/>
             </a:solidFill>
             <a:prstDash val="solid"/>
           </a:ln>
@@ -3060,7 +3060,7 @@
       </p:sp>
       <p:pic>
         <p:nvPicPr>
-          <p:cNvPr id="4" name="Image 0" descr="/Users/lucasb/Escritorio - MacBook Air de Lucas/Fornitalia/favicon.svg">    </p:cNvPr>
+          <p:cNvPr id="4" name="Image 0" descr="preencoded.png">    </p:cNvPr>
           <p:cNvPicPr>
             <a:picLocks noChangeAspect="1"/>
           </p:cNvPicPr>
@@ -3568,11 +3568,11 @@
             <a:avLst/>
           </a:prstGeom>
           <a:solidFill>
-            <a:srgbClr val="0D2137"/>
+            <a:srgbClr val="FFFFFF"/>
           </a:solidFill>
           <a:ln w="19050">
             <a:solidFill>
-              <a:srgbClr val="FFFFFF"/>
+              <a:srgbClr val="0D2137"/>
             </a:solidFill>
             <a:prstDash val="solid"/>
           </a:ln>
@@ -3580,7 +3580,7 @@
       </p:sp>
       <p:pic>
         <p:nvPicPr>
-          <p:cNvPr id="4" name="Image 0" descr="/Users/lucasb/Escritorio - MacBook Air de Lucas/Fornitalia/favicon.svg">    </p:cNvPr>
+          <p:cNvPr id="4" name="Image 0" descr="preencoded.png">    </p:cNvPr>
           <p:cNvPicPr>
             <a:picLocks noChangeAspect="1"/>
           </p:cNvPicPr>
@@ -6258,11 +6258,11 @@
             <a:avLst/>
           </a:prstGeom>
           <a:solidFill>
-            <a:srgbClr val="0D2137"/>
+            <a:srgbClr val="FFFFFF"/>
           </a:solidFill>
           <a:ln w="19050">
             <a:solidFill>
-              <a:srgbClr val="FFFFFF"/>
+              <a:srgbClr val="0D2137"/>
             </a:solidFill>
             <a:prstDash val="solid"/>
           </a:ln>
@@ -6270,7 +6270,7 @@
       </p:sp>
       <p:pic>
         <p:nvPicPr>
-          <p:cNvPr id="4" name="Image 0" descr="/Users/lucasb/Escritorio - MacBook Air de Lucas/Fornitalia/favicon.svg">    </p:cNvPr>
+          <p:cNvPr id="4" name="Image 0" descr="preencoded.png">    </p:cNvPr>
           <p:cNvPicPr>
             <a:picLocks noChangeAspect="1"/>
           </p:cNvPicPr>

</xml_diff>

<commit_message>
v1.43: módulo seguridad, tablas sticky, scroll flujo y bitácora
Made-with: Cursor
</commit_message>
<xml_diff>
--- a/Propuesta_Dashboard_Flujo_Caja.pptx
+++ b/Propuesta_Dashboard_Flujo_Caja.pptx
@@ -5774,6 +5774,203 @@
                           <a:ea typeface="Calibri" pitchFamily="34" charset="-122"/>
                           <a:cs typeface="Calibri" pitchFamily="34" charset="-120"/>
                         </a:rPr>
+                        <a:t>Seguridad y roles (dashboard)</a:t>
+                      </a:r>
+                      <a:endParaRPr lang="en-US" sz="1000" dirty="0">
+                        <a:latin typeface="Calibri" charset="0"/>
+                        <a:ea typeface="Calibri" charset="0"/>
+                        <a:cs typeface="Calibri" charset="0"/>
+                      </a:endParaRPr>
+                    </a:p>
+                  </a:txBody>
+                  <a:tcPr marL="50800" marR="50800" marT="50800" marB="50800" anchor="ctr">
+                    <a:lnL w="6350" cap="flat" cmpd="sng" algn="ctr">
+                      <a:solidFill>
+                        <a:srgbClr val="CCCCCC"/>
+                      </a:solidFill>
+                      <a:prstDash val="solid"/>
+                      <a:round/>
+                      <a:headEnd type="none" w="med" len="med"/>
+                      <a:tailEnd type="none" w="med" len="med"/>
+                    </a:lnL>
+                    <a:lnR w="6350" cap="flat" cmpd="sng" algn="ctr">
+                      <a:solidFill>
+                        <a:srgbClr val="CCCCCC"/>
+                      </a:solidFill>
+                      <a:prstDash val="solid"/>
+                      <a:round/>
+                      <a:headEnd type="none" w="med" len="med"/>
+                      <a:tailEnd type="none" w="med" len="med"/>
+                    </a:lnR>
+                    <a:lnT w="6350" cap="flat" cmpd="sng" algn="ctr">
+                      <a:solidFill>
+                        <a:srgbClr val="CCCCCC"/>
+                      </a:solidFill>
+                      <a:prstDash val="solid"/>
+                      <a:round/>
+                      <a:headEnd type="none" w="med" len="med"/>
+                      <a:tailEnd type="none" w="med" len="med"/>
+                    </a:lnT>
+                    <a:lnB w="6350" cap="flat" cmpd="sng" algn="ctr">
+                      <a:solidFill>
+                        <a:srgbClr val="CCCCCC"/>
+                      </a:solidFill>
+                      <a:prstDash val="solid"/>
+                      <a:round/>
+                      <a:headEnd type="none" w="med" len="med"/>
+                      <a:tailEnd type="none" w="med" len="med"/>
+                    </a:lnB>
+                  </a:tcPr>
+                </a:tc>
+                <a:tc>
+                  <a:txBody>
+                    <a:bodyPr/>
+                    <a:lstStyle/>
+                    <a:p>
+                      <a:pPr algn="l" indent="0" marL="0">
+                        <a:buNone/>
+                      </a:pPr>
+                      <a:r>
+                        <a:rPr lang="en-US" sz="1000" dirty="0">
+                          <a:solidFill>
+                            <a:srgbClr val="000000"/>
+                          </a:solidFill>
+                          <a:latin typeface="Calibri" pitchFamily="34" charset="0"/>
+                          <a:ea typeface="Calibri" pitchFamily="34" charset="-122"/>
+                          <a:cs typeface="Calibri" pitchFamily="34" charset="-120"/>
+                        </a:rPr>
+                        <a:t>18</a:t>
+                      </a:r>
+                      <a:endParaRPr lang="en-US" sz="1000" dirty="0">
+                        <a:latin typeface="Calibri" charset="0"/>
+                        <a:ea typeface="Calibri" charset="0"/>
+                        <a:cs typeface="Calibri" charset="0"/>
+                      </a:endParaRPr>
+                    </a:p>
+                  </a:txBody>
+                  <a:tcPr marL="50800" marR="50800" marT="50800" marB="50800" anchor="ctr">
+                    <a:lnL w="6350" cap="flat" cmpd="sng" algn="ctr">
+                      <a:solidFill>
+                        <a:srgbClr val="CCCCCC"/>
+                      </a:solidFill>
+                      <a:prstDash val="solid"/>
+                      <a:round/>
+                      <a:headEnd type="none" w="med" len="med"/>
+                      <a:tailEnd type="none" w="med" len="med"/>
+                    </a:lnL>
+                    <a:lnR w="6350" cap="flat" cmpd="sng" algn="ctr">
+                      <a:solidFill>
+                        <a:srgbClr val="CCCCCC"/>
+                      </a:solidFill>
+                      <a:prstDash val="solid"/>
+                      <a:round/>
+                      <a:headEnd type="none" w="med" len="med"/>
+                      <a:tailEnd type="none" w="med" len="med"/>
+                    </a:lnR>
+                    <a:lnT w="6350" cap="flat" cmpd="sng" algn="ctr">
+                      <a:solidFill>
+                        <a:srgbClr val="CCCCCC"/>
+                      </a:solidFill>
+                      <a:prstDash val="solid"/>
+                      <a:round/>
+                      <a:headEnd type="none" w="med" len="med"/>
+                      <a:tailEnd type="none" w="med" len="med"/>
+                    </a:lnT>
+                    <a:lnB w="6350" cap="flat" cmpd="sng" algn="ctr">
+                      <a:solidFill>
+                        <a:srgbClr val="CCCCCC"/>
+                      </a:solidFill>
+                      <a:prstDash val="solid"/>
+                      <a:round/>
+                      <a:headEnd type="none" w="med" len="med"/>
+                      <a:tailEnd type="none" w="med" len="med"/>
+                    </a:lnB>
+                  </a:tcPr>
+                </a:tc>
+                <a:tc>
+                  <a:txBody>
+                    <a:bodyPr/>
+                    <a:lstStyle/>
+                    <a:p>
+                      <a:pPr algn="l" indent="0" marL="0">
+                        <a:buNone/>
+                      </a:pPr>
+                      <a:r>
+                        <a:rPr lang="en-US" sz="1000" dirty="0">
+                          <a:solidFill>
+                            <a:srgbClr val="000000"/>
+                          </a:solidFill>
+                          <a:latin typeface="Calibri" pitchFamily="34" charset="0"/>
+                          <a:ea typeface="Calibri" pitchFamily="34" charset="-122"/>
+                          <a:cs typeface="Calibri" pitchFamily="34" charset="-120"/>
+                        </a:rPr>
+                        <a:t>0</a:t>
+                      </a:r>
+                      <a:endParaRPr lang="en-US" sz="1000" dirty="0">
+                        <a:latin typeface="Calibri" charset="0"/>
+                        <a:ea typeface="Calibri" charset="0"/>
+                        <a:cs typeface="Calibri" charset="0"/>
+                      </a:endParaRPr>
+                    </a:p>
+                  </a:txBody>
+                  <a:tcPr marL="50800" marR="50800" marT="50800" marB="50800" anchor="ctr">
+                    <a:lnL w="6350" cap="flat" cmpd="sng" algn="ctr">
+                      <a:solidFill>
+                        <a:srgbClr val="CCCCCC"/>
+                      </a:solidFill>
+                      <a:prstDash val="solid"/>
+                      <a:round/>
+                      <a:headEnd type="none" w="med" len="med"/>
+                      <a:tailEnd type="none" w="med" len="med"/>
+                    </a:lnL>
+                    <a:lnR w="6350" cap="flat" cmpd="sng" algn="ctr">
+                      <a:solidFill>
+                        <a:srgbClr val="CCCCCC"/>
+                      </a:solidFill>
+                      <a:prstDash val="solid"/>
+                      <a:round/>
+                      <a:headEnd type="none" w="med" len="med"/>
+                      <a:tailEnd type="none" w="med" len="med"/>
+                    </a:lnR>
+                    <a:lnT w="6350" cap="flat" cmpd="sng" algn="ctr">
+                      <a:solidFill>
+                        <a:srgbClr val="CCCCCC"/>
+                      </a:solidFill>
+                      <a:prstDash val="solid"/>
+                      <a:round/>
+                      <a:headEnd type="none" w="med" len="med"/>
+                      <a:tailEnd type="none" w="med" len="med"/>
+                    </a:lnT>
+                    <a:lnB w="6350" cap="flat" cmpd="sng" algn="ctr">
+                      <a:solidFill>
+                        <a:srgbClr val="CCCCCC"/>
+                      </a:solidFill>
+                      <a:prstDash val="solid"/>
+                      <a:round/>
+                      <a:headEnd type="none" w="med" len="med"/>
+                      <a:tailEnd type="none" w="med" len="med"/>
+                    </a:lnB>
+                  </a:tcPr>
+                </a:tc>
+              </a:tr>
+              <a:tr h="0">
+                <a:tc>
+                  <a:txBody>
+                    <a:bodyPr/>
+                    <a:lstStyle/>
+                    <a:p>
+                      <a:pPr algn="l" indent="0" marL="0">
+                        <a:buNone/>
+                      </a:pPr>
+                      <a:r>
+                        <a:rPr lang="en-US" sz="1000" dirty="0">
+                          <a:solidFill>
+                            <a:srgbClr val="000000"/>
+                          </a:solidFill>
+                          <a:latin typeface="Calibri" pitchFamily="34" charset="0"/>
+                          <a:ea typeface="Calibri" pitchFamily="34" charset="-122"/>
+                          <a:cs typeface="Calibri" pitchFamily="34" charset="-120"/>
+                        </a:rPr>
                         <a:t>Mantenimiento y soporte inicial</a:t>
                       </a:r>
                       <a:endParaRPr lang="en-US" sz="1000" dirty="0">
@@ -6036,7 +6233,7 @@
                           <a:ea typeface="Calibri" pitchFamily="34" charset="-122"/>
                           <a:cs typeface="Calibri" pitchFamily="34" charset="-120"/>
                         </a:rPr>
-                        <a:t>55</a:t>
+                        <a:t>73</a:t>
                       </a:r>
                       <a:endParaRPr lang="en-US" sz="1000" dirty="0">
                         <a:latin typeface="Calibri" charset="0"/>
@@ -6187,7 +6384,7 @@
                 <a:ea typeface="Calibri" pitchFamily="34" charset="-122"/>
                 <a:cs typeface="Calibri" pitchFamily="34" charset="-120"/>
               </a:rPr>
-              <a:t>Total: 55 horas hombre · 5,500 USD</a:t>
+              <a:t>Total: 73 horas hombre · 5,500 USD</a:t>
             </a:r>
             <a:endParaRPr lang="en-US" sz="1200" dirty="0"/>
           </a:p>

</xml_diff>

<commit_message>
v2.09: Gestión de Proyectos a producción (horas, SPI, observaciones y Gantt).
Co-authored-by: Cursor <cursoragent@cursor.com>
</commit_message>
<xml_diff>
--- a/Propuesta_Dashboard_Flujo_Caja.pptx
+++ b/Propuesta_Dashboard_Flujo_Caja.pptx
@@ -6168,7 +6168,7 @@
                           <a:ea typeface="Calibri" pitchFamily="34" charset="-122"/>
                           <a:cs typeface="Calibri" pitchFamily="34" charset="-120"/>
                         </a:rPr>
-                        <a:t>Total</a:t>
+                        <a:t>Gestión de Proyectos</a:t>
                       </a:r>
                       <a:endParaRPr lang="en-US" sz="1000" dirty="0">
                         <a:latin typeface="Calibri" charset="0"/>
@@ -6233,7 +6233,204 @@
                           <a:ea typeface="Calibri" pitchFamily="34" charset="-122"/>
                           <a:cs typeface="Calibri" pitchFamily="34" charset="-120"/>
                         </a:rPr>
-                        <a:t>73</a:t>
+                        <a:t>40</a:t>
+                      </a:r>
+                      <a:endParaRPr lang="en-US" sz="1000" dirty="0">
+                        <a:latin typeface="Calibri" charset="0"/>
+                        <a:ea typeface="Calibri" charset="0"/>
+                        <a:cs typeface="Calibri" charset="0"/>
+                      </a:endParaRPr>
+                    </a:p>
+                  </a:txBody>
+                  <a:tcPr marL="50800" marR="50800" marT="50800" marB="50800" anchor="ctr">
+                    <a:lnL w="6350" cap="flat" cmpd="sng" algn="ctr">
+                      <a:solidFill>
+                        <a:srgbClr val="CCCCCC"/>
+                      </a:solidFill>
+                      <a:prstDash val="solid"/>
+                      <a:round/>
+                      <a:headEnd type="none" w="med" len="med"/>
+                      <a:tailEnd type="none" w="med" len="med"/>
+                    </a:lnL>
+                    <a:lnR w="6350" cap="flat" cmpd="sng" algn="ctr">
+                      <a:solidFill>
+                        <a:srgbClr val="CCCCCC"/>
+                      </a:solidFill>
+                      <a:prstDash val="solid"/>
+                      <a:round/>
+                      <a:headEnd type="none" w="med" len="med"/>
+                      <a:tailEnd type="none" w="med" len="med"/>
+                    </a:lnR>
+                    <a:lnT w="6350" cap="flat" cmpd="sng" algn="ctr">
+                      <a:solidFill>
+                        <a:srgbClr val="CCCCCC"/>
+                      </a:solidFill>
+                      <a:prstDash val="solid"/>
+                      <a:round/>
+                      <a:headEnd type="none" w="med" len="med"/>
+                      <a:tailEnd type="none" w="med" len="med"/>
+                    </a:lnT>
+                    <a:lnB w="6350" cap="flat" cmpd="sng" algn="ctr">
+                      <a:solidFill>
+                        <a:srgbClr val="CCCCCC"/>
+                      </a:solidFill>
+                      <a:prstDash val="solid"/>
+                      <a:round/>
+                      <a:headEnd type="none" w="med" len="med"/>
+                      <a:tailEnd type="none" w="med" len="med"/>
+                    </a:lnB>
+                  </a:tcPr>
+                </a:tc>
+                <a:tc>
+                  <a:txBody>
+                    <a:bodyPr/>
+                    <a:lstStyle/>
+                    <a:p>
+                      <a:pPr algn="l" indent="0" marL="0">
+                        <a:buNone/>
+                      </a:pPr>
+                      <a:r>
+                        <a:rPr lang="en-US" sz="1000" dirty="0">
+                          <a:solidFill>
+                            <a:srgbClr val="000000"/>
+                          </a:solidFill>
+                          <a:latin typeface="Calibri" pitchFamily="34" charset="0"/>
+                          <a:ea typeface="Calibri" pitchFamily="34" charset="-122"/>
+                          <a:cs typeface="Calibri" pitchFamily="34" charset="-120"/>
+                        </a:rPr>
+                        <a:t>0</a:t>
+                      </a:r>
+                      <a:endParaRPr lang="en-US" sz="1000" dirty="0">
+                        <a:latin typeface="Calibri" charset="0"/>
+                        <a:ea typeface="Calibri" charset="0"/>
+                        <a:cs typeface="Calibri" charset="0"/>
+                      </a:endParaRPr>
+                    </a:p>
+                  </a:txBody>
+                  <a:tcPr marL="50800" marR="50800" marT="50800" marB="50800" anchor="ctr">
+                    <a:lnL w="6350" cap="flat" cmpd="sng" algn="ctr">
+                      <a:solidFill>
+                        <a:srgbClr val="CCCCCC"/>
+                      </a:solidFill>
+                      <a:prstDash val="solid"/>
+                      <a:round/>
+                      <a:headEnd type="none" w="med" len="med"/>
+                      <a:tailEnd type="none" w="med" len="med"/>
+                    </a:lnL>
+                    <a:lnR w="6350" cap="flat" cmpd="sng" algn="ctr">
+                      <a:solidFill>
+                        <a:srgbClr val="CCCCCC"/>
+                      </a:solidFill>
+                      <a:prstDash val="solid"/>
+                      <a:round/>
+                      <a:headEnd type="none" w="med" len="med"/>
+                      <a:tailEnd type="none" w="med" len="med"/>
+                    </a:lnR>
+                    <a:lnT w="6350" cap="flat" cmpd="sng" algn="ctr">
+                      <a:solidFill>
+                        <a:srgbClr val="CCCCCC"/>
+                      </a:solidFill>
+                      <a:prstDash val="solid"/>
+                      <a:round/>
+                      <a:headEnd type="none" w="med" len="med"/>
+                      <a:tailEnd type="none" w="med" len="med"/>
+                    </a:lnT>
+                    <a:lnB w="6350" cap="flat" cmpd="sng" algn="ctr">
+                      <a:solidFill>
+                        <a:srgbClr val="CCCCCC"/>
+                      </a:solidFill>
+                      <a:prstDash val="solid"/>
+                      <a:round/>
+                      <a:headEnd type="none" w="med" len="med"/>
+                      <a:tailEnd type="none" w="med" len="med"/>
+                    </a:lnB>
+                  </a:tcPr>
+                </a:tc>
+              </a:tr>
+              <a:tr h="0">
+                <a:tc>
+                  <a:txBody>
+                    <a:bodyPr/>
+                    <a:lstStyle/>
+                    <a:p>
+                      <a:pPr algn="l" indent="0" marL="0">
+                        <a:buNone/>
+                      </a:pPr>
+                      <a:r>
+                        <a:rPr lang="en-US" sz="1000" dirty="0">
+                          <a:solidFill>
+                            <a:srgbClr val="000000"/>
+                          </a:solidFill>
+                          <a:latin typeface="Calibri" pitchFamily="34" charset="0"/>
+                          <a:ea typeface="Calibri" pitchFamily="34" charset="-122"/>
+                          <a:cs typeface="Calibri" pitchFamily="34" charset="-120"/>
+                        </a:rPr>
+                        <a:t>Total</a:t>
+                      </a:r>
+                      <a:endParaRPr lang="en-US" sz="1000" dirty="0">
+                        <a:latin typeface="Calibri" charset="0"/>
+                        <a:ea typeface="Calibri" charset="0"/>
+                        <a:cs typeface="Calibri" charset="0"/>
+                      </a:endParaRPr>
+                    </a:p>
+                  </a:txBody>
+                  <a:tcPr marL="50800" marR="50800" marT="50800" marB="50800" anchor="ctr">
+                    <a:lnL w="6350" cap="flat" cmpd="sng" algn="ctr">
+                      <a:solidFill>
+                        <a:srgbClr val="CCCCCC"/>
+                      </a:solidFill>
+                      <a:prstDash val="solid"/>
+                      <a:round/>
+                      <a:headEnd type="none" w="med" len="med"/>
+                      <a:tailEnd type="none" w="med" len="med"/>
+                    </a:lnL>
+                    <a:lnR w="6350" cap="flat" cmpd="sng" algn="ctr">
+                      <a:solidFill>
+                        <a:srgbClr val="CCCCCC"/>
+                      </a:solidFill>
+                      <a:prstDash val="solid"/>
+                      <a:round/>
+                      <a:headEnd type="none" w="med" len="med"/>
+                      <a:tailEnd type="none" w="med" len="med"/>
+                    </a:lnR>
+                    <a:lnT w="6350" cap="flat" cmpd="sng" algn="ctr">
+                      <a:solidFill>
+                        <a:srgbClr val="CCCCCC"/>
+                      </a:solidFill>
+                      <a:prstDash val="solid"/>
+                      <a:round/>
+                      <a:headEnd type="none" w="med" len="med"/>
+                      <a:tailEnd type="none" w="med" len="med"/>
+                    </a:lnT>
+                    <a:lnB w="6350" cap="flat" cmpd="sng" algn="ctr">
+                      <a:solidFill>
+                        <a:srgbClr val="CCCCCC"/>
+                      </a:solidFill>
+                      <a:prstDash val="solid"/>
+                      <a:round/>
+                      <a:headEnd type="none" w="med" len="med"/>
+                      <a:tailEnd type="none" w="med" len="med"/>
+                    </a:lnB>
+                  </a:tcPr>
+                </a:tc>
+                <a:tc>
+                  <a:txBody>
+                    <a:bodyPr/>
+                    <a:lstStyle/>
+                    <a:p>
+                      <a:pPr algn="l" indent="0" marL="0">
+                        <a:buNone/>
+                      </a:pPr>
+                      <a:r>
+                        <a:rPr lang="en-US" sz="1000" dirty="0">
+                          <a:solidFill>
+                            <a:srgbClr val="000000"/>
+                          </a:solidFill>
+                          <a:latin typeface="Calibri" pitchFamily="34" charset="0"/>
+                          <a:ea typeface="Calibri" pitchFamily="34" charset="-122"/>
+                          <a:cs typeface="Calibri" pitchFamily="34" charset="-120"/>
+                        </a:rPr>
+                        <a:t>113</a:t>
                       </a:r>
                       <a:endParaRPr lang="en-US" sz="1000" dirty="0">
                         <a:latin typeface="Calibri" charset="0"/>
@@ -6384,7 +6581,7 @@
                 <a:ea typeface="Calibri" pitchFamily="34" charset="-122"/>
                 <a:cs typeface="Calibri" pitchFamily="34" charset="-120"/>
               </a:rPr>
-              <a:t>Total: 73 horas hombre · 5,500 USD</a:t>
+              <a:t>Total: 113 horas hombre · 5,500 USD</a:t>
             </a:r>
             <a:endParaRPr lang="en-US" sz="1200" dirty="0"/>
           </a:p>

</xml_diff>

<commit_message>
v2.12: Conciliación Bancaria (Mercado Pago y Galicia).
Co-authored-by: Cursor <cursoragent@cursor.com>
</commit_message>
<xml_diff>
--- a/Propuesta_Dashboard_Flujo_Caja.pptx
+++ b/Propuesta_Dashboard_Flujo_Caja.pptx
@@ -6365,7 +6365,7 @@
                           <a:ea typeface="Calibri" pitchFamily="34" charset="-122"/>
                           <a:cs typeface="Calibri" pitchFamily="34" charset="-120"/>
                         </a:rPr>
-                        <a:t>Total</a:t>
+                        <a:t>Conciliación Bancaria</a:t>
                       </a:r>
                       <a:endParaRPr lang="en-US" sz="1000" dirty="0">
                         <a:latin typeface="Calibri" charset="0"/>
@@ -6430,7 +6430,204 @@
                           <a:ea typeface="Calibri" pitchFamily="34" charset="-122"/>
                           <a:cs typeface="Calibri" pitchFamily="34" charset="-120"/>
                         </a:rPr>
-                        <a:t>113</a:t>
+                        <a:t>24</a:t>
+                      </a:r>
+                      <a:endParaRPr lang="en-US" sz="1000" dirty="0">
+                        <a:latin typeface="Calibri" charset="0"/>
+                        <a:ea typeface="Calibri" charset="0"/>
+                        <a:cs typeface="Calibri" charset="0"/>
+                      </a:endParaRPr>
+                    </a:p>
+                  </a:txBody>
+                  <a:tcPr marL="50800" marR="50800" marT="50800" marB="50800" anchor="ctr">
+                    <a:lnL w="6350" cap="flat" cmpd="sng" algn="ctr">
+                      <a:solidFill>
+                        <a:srgbClr val="CCCCCC"/>
+                      </a:solidFill>
+                      <a:prstDash val="solid"/>
+                      <a:round/>
+                      <a:headEnd type="none" w="med" len="med"/>
+                      <a:tailEnd type="none" w="med" len="med"/>
+                    </a:lnL>
+                    <a:lnR w="6350" cap="flat" cmpd="sng" algn="ctr">
+                      <a:solidFill>
+                        <a:srgbClr val="CCCCCC"/>
+                      </a:solidFill>
+                      <a:prstDash val="solid"/>
+                      <a:round/>
+                      <a:headEnd type="none" w="med" len="med"/>
+                      <a:tailEnd type="none" w="med" len="med"/>
+                    </a:lnR>
+                    <a:lnT w="6350" cap="flat" cmpd="sng" algn="ctr">
+                      <a:solidFill>
+                        <a:srgbClr val="CCCCCC"/>
+                      </a:solidFill>
+                      <a:prstDash val="solid"/>
+                      <a:round/>
+                      <a:headEnd type="none" w="med" len="med"/>
+                      <a:tailEnd type="none" w="med" len="med"/>
+                    </a:lnT>
+                    <a:lnB w="6350" cap="flat" cmpd="sng" algn="ctr">
+                      <a:solidFill>
+                        <a:srgbClr val="CCCCCC"/>
+                      </a:solidFill>
+                      <a:prstDash val="solid"/>
+                      <a:round/>
+                      <a:headEnd type="none" w="med" len="med"/>
+                      <a:tailEnd type="none" w="med" len="med"/>
+                    </a:lnB>
+                  </a:tcPr>
+                </a:tc>
+                <a:tc>
+                  <a:txBody>
+                    <a:bodyPr/>
+                    <a:lstStyle/>
+                    <a:p>
+                      <a:pPr algn="l" indent="0" marL="0">
+                        <a:buNone/>
+                      </a:pPr>
+                      <a:r>
+                        <a:rPr lang="en-US" sz="1000" dirty="0">
+                          <a:solidFill>
+                            <a:srgbClr val="000000"/>
+                          </a:solidFill>
+                          <a:latin typeface="Calibri" pitchFamily="34" charset="0"/>
+                          <a:ea typeface="Calibri" pitchFamily="34" charset="-122"/>
+                          <a:cs typeface="Calibri" pitchFamily="34" charset="-120"/>
+                        </a:rPr>
+                        <a:t>0</a:t>
+                      </a:r>
+                      <a:endParaRPr lang="en-US" sz="1000" dirty="0">
+                        <a:latin typeface="Calibri" charset="0"/>
+                        <a:ea typeface="Calibri" charset="0"/>
+                        <a:cs typeface="Calibri" charset="0"/>
+                      </a:endParaRPr>
+                    </a:p>
+                  </a:txBody>
+                  <a:tcPr marL="50800" marR="50800" marT="50800" marB="50800" anchor="ctr">
+                    <a:lnL w="6350" cap="flat" cmpd="sng" algn="ctr">
+                      <a:solidFill>
+                        <a:srgbClr val="CCCCCC"/>
+                      </a:solidFill>
+                      <a:prstDash val="solid"/>
+                      <a:round/>
+                      <a:headEnd type="none" w="med" len="med"/>
+                      <a:tailEnd type="none" w="med" len="med"/>
+                    </a:lnL>
+                    <a:lnR w="6350" cap="flat" cmpd="sng" algn="ctr">
+                      <a:solidFill>
+                        <a:srgbClr val="CCCCCC"/>
+                      </a:solidFill>
+                      <a:prstDash val="solid"/>
+                      <a:round/>
+                      <a:headEnd type="none" w="med" len="med"/>
+                      <a:tailEnd type="none" w="med" len="med"/>
+                    </a:lnR>
+                    <a:lnT w="6350" cap="flat" cmpd="sng" algn="ctr">
+                      <a:solidFill>
+                        <a:srgbClr val="CCCCCC"/>
+                      </a:solidFill>
+                      <a:prstDash val="solid"/>
+                      <a:round/>
+                      <a:headEnd type="none" w="med" len="med"/>
+                      <a:tailEnd type="none" w="med" len="med"/>
+                    </a:lnT>
+                    <a:lnB w="6350" cap="flat" cmpd="sng" algn="ctr">
+                      <a:solidFill>
+                        <a:srgbClr val="CCCCCC"/>
+                      </a:solidFill>
+                      <a:prstDash val="solid"/>
+                      <a:round/>
+                      <a:headEnd type="none" w="med" len="med"/>
+                      <a:tailEnd type="none" w="med" len="med"/>
+                    </a:lnB>
+                  </a:tcPr>
+                </a:tc>
+              </a:tr>
+              <a:tr h="0">
+                <a:tc>
+                  <a:txBody>
+                    <a:bodyPr/>
+                    <a:lstStyle/>
+                    <a:p>
+                      <a:pPr algn="l" indent="0" marL="0">
+                        <a:buNone/>
+                      </a:pPr>
+                      <a:r>
+                        <a:rPr lang="en-US" sz="1000" dirty="0">
+                          <a:solidFill>
+                            <a:srgbClr val="000000"/>
+                          </a:solidFill>
+                          <a:latin typeface="Calibri" pitchFamily="34" charset="0"/>
+                          <a:ea typeface="Calibri" pitchFamily="34" charset="-122"/>
+                          <a:cs typeface="Calibri" pitchFamily="34" charset="-120"/>
+                        </a:rPr>
+                        <a:t>Total</a:t>
+                      </a:r>
+                      <a:endParaRPr lang="en-US" sz="1000" dirty="0">
+                        <a:latin typeface="Calibri" charset="0"/>
+                        <a:ea typeface="Calibri" charset="0"/>
+                        <a:cs typeface="Calibri" charset="0"/>
+                      </a:endParaRPr>
+                    </a:p>
+                  </a:txBody>
+                  <a:tcPr marL="50800" marR="50800" marT="50800" marB="50800" anchor="ctr">
+                    <a:lnL w="6350" cap="flat" cmpd="sng" algn="ctr">
+                      <a:solidFill>
+                        <a:srgbClr val="CCCCCC"/>
+                      </a:solidFill>
+                      <a:prstDash val="solid"/>
+                      <a:round/>
+                      <a:headEnd type="none" w="med" len="med"/>
+                      <a:tailEnd type="none" w="med" len="med"/>
+                    </a:lnL>
+                    <a:lnR w="6350" cap="flat" cmpd="sng" algn="ctr">
+                      <a:solidFill>
+                        <a:srgbClr val="CCCCCC"/>
+                      </a:solidFill>
+                      <a:prstDash val="solid"/>
+                      <a:round/>
+                      <a:headEnd type="none" w="med" len="med"/>
+                      <a:tailEnd type="none" w="med" len="med"/>
+                    </a:lnR>
+                    <a:lnT w="6350" cap="flat" cmpd="sng" algn="ctr">
+                      <a:solidFill>
+                        <a:srgbClr val="CCCCCC"/>
+                      </a:solidFill>
+                      <a:prstDash val="solid"/>
+                      <a:round/>
+                      <a:headEnd type="none" w="med" len="med"/>
+                      <a:tailEnd type="none" w="med" len="med"/>
+                    </a:lnT>
+                    <a:lnB w="6350" cap="flat" cmpd="sng" algn="ctr">
+                      <a:solidFill>
+                        <a:srgbClr val="CCCCCC"/>
+                      </a:solidFill>
+                      <a:prstDash val="solid"/>
+                      <a:round/>
+                      <a:headEnd type="none" w="med" len="med"/>
+                      <a:tailEnd type="none" w="med" len="med"/>
+                    </a:lnB>
+                  </a:tcPr>
+                </a:tc>
+                <a:tc>
+                  <a:txBody>
+                    <a:bodyPr/>
+                    <a:lstStyle/>
+                    <a:p>
+                      <a:pPr algn="l" indent="0" marL="0">
+                        <a:buNone/>
+                      </a:pPr>
+                      <a:r>
+                        <a:rPr lang="en-US" sz="1000" dirty="0">
+                          <a:solidFill>
+                            <a:srgbClr val="000000"/>
+                          </a:solidFill>
+                          <a:latin typeface="Calibri" pitchFamily="34" charset="0"/>
+                          <a:ea typeface="Calibri" pitchFamily="34" charset="-122"/>
+                          <a:cs typeface="Calibri" pitchFamily="34" charset="-120"/>
+                        </a:rPr>
+                        <a:t>137</a:t>
                       </a:r>
                       <a:endParaRPr lang="en-US" sz="1000" dirty="0">
                         <a:latin typeface="Calibri" charset="0"/>
@@ -6581,7 +6778,7 @@
                 <a:ea typeface="Calibri" pitchFamily="34" charset="-122"/>
                 <a:cs typeface="Calibri" pitchFamily="34" charset="-120"/>
               </a:rPr>
-              <a:t>Total: 113 horas hombre · 5,500 USD</a:t>
+              <a:t>Total: 137 horas hombre · 5,500 USD</a:t>
             </a:r>
             <a:endParaRPr lang="en-US" sz="1200" dirty="0"/>
           </a:p>

</xml_diff>

<commit_message>
v2.16: menú Saldos extractos (Galicia) con tabla, gráfico y permisos.
Co-authored-by: Cursor <cursoragent@cursor.com>
</commit_message>
<xml_diff>
--- a/Propuesta_Dashboard_Flujo_Caja.pptx
+++ b/Propuesta_Dashboard_Flujo_Caja.pptx
@@ -6562,7 +6562,7 @@
                           <a:ea typeface="Calibri" pitchFamily="34" charset="-122"/>
                           <a:cs typeface="Calibri" pitchFamily="34" charset="-120"/>
                         </a:rPr>
-                        <a:t>Total</a:t>
+                        <a:t>Saldos extractos bancarios</a:t>
                       </a:r>
                       <a:endParaRPr lang="en-US" sz="1000" dirty="0">
                         <a:latin typeface="Calibri" charset="0"/>
@@ -6627,7 +6627,204 @@
                           <a:ea typeface="Calibri" pitchFamily="34" charset="-122"/>
                           <a:cs typeface="Calibri" pitchFamily="34" charset="-120"/>
                         </a:rPr>
-                        <a:t>137</a:t>
+                        <a:t>12</a:t>
+                      </a:r>
+                      <a:endParaRPr lang="en-US" sz="1000" dirty="0">
+                        <a:latin typeface="Calibri" charset="0"/>
+                        <a:ea typeface="Calibri" charset="0"/>
+                        <a:cs typeface="Calibri" charset="0"/>
+                      </a:endParaRPr>
+                    </a:p>
+                  </a:txBody>
+                  <a:tcPr marL="50800" marR="50800" marT="50800" marB="50800" anchor="ctr">
+                    <a:lnL w="6350" cap="flat" cmpd="sng" algn="ctr">
+                      <a:solidFill>
+                        <a:srgbClr val="CCCCCC"/>
+                      </a:solidFill>
+                      <a:prstDash val="solid"/>
+                      <a:round/>
+                      <a:headEnd type="none" w="med" len="med"/>
+                      <a:tailEnd type="none" w="med" len="med"/>
+                    </a:lnL>
+                    <a:lnR w="6350" cap="flat" cmpd="sng" algn="ctr">
+                      <a:solidFill>
+                        <a:srgbClr val="CCCCCC"/>
+                      </a:solidFill>
+                      <a:prstDash val="solid"/>
+                      <a:round/>
+                      <a:headEnd type="none" w="med" len="med"/>
+                      <a:tailEnd type="none" w="med" len="med"/>
+                    </a:lnR>
+                    <a:lnT w="6350" cap="flat" cmpd="sng" algn="ctr">
+                      <a:solidFill>
+                        <a:srgbClr val="CCCCCC"/>
+                      </a:solidFill>
+                      <a:prstDash val="solid"/>
+                      <a:round/>
+                      <a:headEnd type="none" w="med" len="med"/>
+                      <a:tailEnd type="none" w="med" len="med"/>
+                    </a:lnT>
+                    <a:lnB w="6350" cap="flat" cmpd="sng" algn="ctr">
+                      <a:solidFill>
+                        <a:srgbClr val="CCCCCC"/>
+                      </a:solidFill>
+                      <a:prstDash val="solid"/>
+                      <a:round/>
+                      <a:headEnd type="none" w="med" len="med"/>
+                      <a:tailEnd type="none" w="med" len="med"/>
+                    </a:lnB>
+                  </a:tcPr>
+                </a:tc>
+                <a:tc>
+                  <a:txBody>
+                    <a:bodyPr/>
+                    <a:lstStyle/>
+                    <a:p>
+                      <a:pPr algn="l" indent="0" marL="0">
+                        <a:buNone/>
+                      </a:pPr>
+                      <a:r>
+                        <a:rPr lang="en-US" sz="1000" dirty="0">
+                          <a:solidFill>
+                            <a:srgbClr val="000000"/>
+                          </a:solidFill>
+                          <a:latin typeface="Calibri" pitchFamily="34" charset="0"/>
+                          <a:ea typeface="Calibri" pitchFamily="34" charset="-122"/>
+                          <a:cs typeface="Calibri" pitchFamily="34" charset="-120"/>
+                        </a:rPr>
+                        <a:t>0</a:t>
+                      </a:r>
+                      <a:endParaRPr lang="en-US" sz="1000" dirty="0">
+                        <a:latin typeface="Calibri" charset="0"/>
+                        <a:ea typeface="Calibri" charset="0"/>
+                        <a:cs typeface="Calibri" charset="0"/>
+                      </a:endParaRPr>
+                    </a:p>
+                  </a:txBody>
+                  <a:tcPr marL="50800" marR="50800" marT="50800" marB="50800" anchor="ctr">
+                    <a:lnL w="6350" cap="flat" cmpd="sng" algn="ctr">
+                      <a:solidFill>
+                        <a:srgbClr val="CCCCCC"/>
+                      </a:solidFill>
+                      <a:prstDash val="solid"/>
+                      <a:round/>
+                      <a:headEnd type="none" w="med" len="med"/>
+                      <a:tailEnd type="none" w="med" len="med"/>
+                    </a:lnL>
+                    <a:lnR w="6350" cap="flat" cmpd="sng" algn="ctr">
+                      <a:solidFill>
+                        <a:srgbClr val="CCCCCC"/>
+                      </a:solidFill>
+                      <a:prstDash val="solid"/>
+                      <a:round/>
+                      <a:headEnd type="none" w="med" len="med"/>
+                      <a:tailEnd type="none" w="med" len="med"/>
+                    </a:lnR>
+                    <a:lnT w="6350" cap="flat" cmpd="sng" algn="ctr">
+                      <a:solidFill>
+                        <a:srgbClr val="CCCCCC"/>
+                      </a:solidFill>
+                      <a:prstDash val="solid"/>
+                      <a:round/>
+                      <a:headEnd type="none" w="med" len="med"/>
+                      <a:tailEnd type="none" w="med" len="med"/>
+                    </a:lnT>
+                    <a:lnB w="6350" cap="flat" cmpd="sng" algn="ctr">
+                      <a:solidFill>
+                        <a:srgbClr val="CCCCCC"/>
+                      </a:solidFill>
+                      <a:prstDash val="solid"/>
+                      <a:round/>
+                      <a:headEnd type="none" w="med" len="med"/>
+                      <a:tailEnd type="none" w="med" len="med"/>
+                    </a:lnB>
+                  </a:tcPr>
+                </a:tc>
+              </a:tr>
+              <a:tr h="0">
+                <a:tc>
+                  <a:txBody>
+                    <a:bodyPr/>
+                    <a:lstStyle/>
+                    <a:p>
+                      <a:pPr algn="l" indent="0" marL="0">
+                        <a:buNone/>
+                      </a:pPr>
+                      <a:r>
+                        <a:rPr lang="en-US" sz="1000" dirty="0">
+                          <a:solidFill>
+                            <a:srgbClr val="000000"/>
+                          </a:solidFill>
+                          <a:latin typeface="Calibri" pitchFamily="34" charset="0"/>
+                          <a:ea typeface="Calibri" pitchFamily="34" charset="-122"/>
+                          <a:cs typeface="Calibri" pitchFamily="34" charset="-120"/>
+                        </a:rPr>
+                        <a:t>Total</a:t>
+                      </a:r>
+                      <a:endParaRPr lang="en-US" sz="1000" dirty="0">
+                        <a:latin typeface="Calibri" charset="0"/>
+                        <a:ea typeface="Calibri" charset="0"/>
+                        <a:cs typeface="Calibri" charset="0"/>
+                      </a:endParaRPr>
+                    </a:p>
+                  </a:txBody>
+                  <a:tcPr marL="50800" marR="50800" marT="50800" marB="50800" anchor="ctr">
+                    <a:lnL w="6350" cap="flat" cmpd="sng" algn="ctr">
+                      <a:solidFill>
+                        <a:srgbClr val="CCCCCC"/>
+                      </a:solidFill>
+                      <a:prstDash val="solid"/>
+                      <a:round/>
+                      <a:headEnd type="none" w="med" len="med"/>
+                      <a:tailEnd type="none" w="med" len="med"/>
+                    </a:lnL>
+                    <a:lnR w="6350" cap="flat" cmpd="sng" algn="ctr">
+                      <a:solidFill>
+                        <a:srgbClr val="CCCCCC"/>
+                      </a:solidFill>
+                      <a:prstDash val="solid"/>
+                      <a:round/>
+                      <a:headEnd type="none" w="med" len="med"/>
+                      <a:tailEnd type="none" w="med" len="med"/>
+                    </a:lnR>
+                    <a:lnT w="6350" cap="flat" cmpd="sng" algn="ctr">
+                      <a:solidFill>
+                        <a:srgbClr val="CCCCCC"/>
+                      </a:solidFill>
+                      <a:prstDash val="solid"/>
+                      <a:round/>
+                      <a:headEnd type="none" w="med" len="med"/>
+                      <a:tailEnd type="none" w="med" len="med"/>
+                    </a:lnT>
+                    <a:lnB w="6350" cap="flat" cmpd="sng" algn="ctr">
+                      <a:solidFill>
+                        <a:srgbClr val="CCCCCC"/>
+                      </a:solidFill>
+                      <a:prstDash val="solid"/>
+                      <a:round/>
+                      <a:headEnd type="none" w="med" len="med"/>
+                      <a:tailEnd type="none" w="med" len="med"/>
+                    </a:lnB>
+                  </a:tcPr>
+                </a:tc>
+                <a:tc>
+                  <a:txBody>
+                    <a:bodyPr/>
+                    <a:lstStyle/>
+                    <a:p>
+                      <a:pPr algn="l" indent="0" marL="0">
+                        <a:buNone/>
+                      </a:pPr>
+                      <a:r>
+                        <a:rPr lang="en-US" sz="1000" dirty="0">
+                          <a:solidFill>
+                            <a:srgbClr val="000000"/>
+                          </a:solidFill>
+                          <a:latin typeface="Calibri" pitchFamily="34" charset="0"/>
+                          <a:ea typeface="Calibri" pitchFamily="34" charset="-122"/>
+                          <a:cs typeface="Calibri" pitchFamily="34" charset="-120"/>
+                        </a:rPr>
+                        <a:t>149</a:t>
                       </a:r>
                       <a:endParaRPr lang="en-US" sz="1000" dirty="0">
                         <a:latin typeface="Calibri" charset="0"/>
@@ -6778,7 +6975,7 @@
                 <a:ea typeface="Calibri" pitchFamily="34" charset="-122"/>
                 <a:cs typeface="Calibri" pitchFamily="34" charset="-120"/>
               </a:rPr>
-              <a:t>Total: 137 horas hombre · 5,500 USD</a:t>
+              <a:t>Total: 149 horas hombre · 5,500 USD</a:t>
             </a:r>
             <a:endParaRPr lang="en-US" sz="1200" dirty="0"/>
           </a:p>

</xml_diff>